<commit_message>
Enable verified sDAI rehearsals and independent Ethereum recovery checks
</commit_message>
<xml_diff>
--- a/docs/submission/ExitDrill-pitch.pptx
+++ b/docs/submission/ExitDrill-pitch.pptx
@@ -2,18 +2,18 @@
 <file path=ppt/presentation.xml><?xml version="1.0" encoding="utf-8"?>
 <p:presentation xmlns:p="http://schemas.openxmlformats.org/presentationml/2006/main">
   <p:sldMasterIdLst>
-    <p:sldMasterId xmlns:r="http://schemas.openxmlformats.org/officeDocument/2006/relationships" id="2147483648" r:id="Rc9e1ab15d78c4f88"/>
+    <p:sldMasterId xmlns:r="http://schemas.openxmlformats.org/officeDocument/2006/relationships" id="2147483648" r:id="R80e34c9d1ad94576"/>
   </p:sldMasterIdLst>
   <p:notesMasterIdLst>
-    <p:notesMasterId xmlns:r="http://schemas.openxmlformats.org/officeDocument/2006/relationships" r:id="Rce8deb937540422f"/>
+    <p:notesMasterId xmlns:r="http://schemas.openxmlformats.org/officeDocument/2006/relationships" r:id="R818789fd9b3f4f36"/>
   </p:notesMasterIdLst>
   <p:sldIdLst>
-    <p:sldId xmlns:r="http://schemas.openxmlformats.org/officeDocument/2006/relationships" id="256" r:id="Re733da19c0a24451"/>
-    <p:sldId xmlns:r="http://schemas.openxmlformats.org/officeDocument/2006/relationships" id="257" r:id="R3b353dc033f74d18"/>
-    <p:sldId xmlns:r="http://schemas.openxmlformats.org/officeDocument/2006/relationships" id="258" r:id="R4a9b192edf134e45"/>
-    <p:sldId xmlns:r="http://schemas.openxmlformats.org/officeDocument/2006/relationships" id="259" r:id="R1fb903199d954b16"/>
-    <p:sldId xmlns:r="http://schemas.openxmlformats.org/officeDocument/2006/relationships" id="260" r:id="R8ed0df9bb4384173"/>
-    <p:sldId xmlns:r="http://schemas.openxmlformats.org/officeDocument/2006/relationships" id="261" r:id="R4a156191c96b414b"/>
+    <p:sldId xmlns:r="http://schemas.openxmlformats.org/officeDocument/2006/relationships" id="256" r:id="R7b45a801d2a44b72"/>
+    <p:sldId xmlns:r="http://schemas.openxmlformats.org/officeDocument/2006/relationships" id="257" r:id="R328a2348c4514f93"/>
+    <p:sldId xmlns:r="http://schemas.openxmlformats.org/officeDocument/2006/relationships" id="258" r:id="R4d82ae26f6794498"/>
+    <p:sldId xmlns:r="http://schemas.openxmlformats.org/officeDocument/2006/relationships" id="259" r:id="Rd44bdbcea81b4d32"/>
+    <p:sldId xmlns:r="http://schemas.openxmlformats.org/officeDocument/2006/relationships" id="260" r:id="R82487085eeb34142"/>
+    <p:sldId xmlns:r="http://schemas.openxmlformats.org/officeDocument/2006/relationships" id="261" r:id="R0407c0f587b84672"/>
   </p:sldIdLst>
   <p:sldSz cx="12192000" cy="6858000"/>
   <p:notesSz cx="6858000" cy="9144000"/>
@@ -849,7 +849,7 @@
   </p:cSld>
   <p:clrMap bg1="lt1" tx1="dk1" bg2="lt2" tx2="dk2" accent1="accent1" accent2="accent2" accent3="accent3" accent4="accent4" accent5="accent5" accent6="accent6" hlink="hlink" folHlink="folHlink"/>
   <p:sldLayoutIdLst>
-    <p:sldLayoutId xmlns:r="http://schemas.openxmlformats.org/officeDocument/2006/relationships" id="2147483649" r:id="R0227694abb1c401e"/>
+    <p:sldLayoutId xmlns:r="http://schemas.openxmlformats.org/officeDocument/2006/relationships" id="2147483649" r:id="R8ab67f6a5fa14d6f"/>
   </p:sldLayoutIdLst>
   <p:txStyles>
     <p:titleStyle>
@@ -1400,7 +1400,7 @@
           <p:cNvPr id="5" name="">
             <a:extLst xmlns:a="http://schemas.openxmlformats.org/drawingml/2006/main">
               <a:ext uri="{FF2B5EF4-FFF2-40B4-BE49-F238E27FC236}">
-                <a16:creationId xmlns:a16="http://schemas.microsoft.com/office/drawing/2014/main" id="{66256210-6230-4194-BC74-CF243BC9147B}"/>
+                <a16:creationId xmlns:a16="http://schemas.microsoft.com/office/drawing/2014/main" id="{A9B3B149-FD7C-4912-AB0D-36B99A045DA9}"/>
               </a:ext>
             </a:extLst>
           </p:cNvPr>
@@ -1457,7 +1457,7 @@
           <p:cNvPr id="2" name="">
             <a:extLst xmlns:a="http://schemas.openxmlformats.org/drawingml/2006/main">
               <a:ext uri="{FF2B5EF4-FFF2-40B4-BE49-F238E27FC236}">
-                <a16:creationId xmlns:a16="http://schemas.microsoft.com/office/drawing/2014/main" id="{FB1DC0B3-A679-47C3-B6D6-6FA283E2C836}"/>
+                <a16:creationId xmlns:a16="http://schemas.microsoft.com/office/drawing/2014/main" id="{23080B87-9CAD-40A5-BE14-9921EDB53FB1}"/>
               </a:ext>
             </a:extLst>
           </p:cNvPr>
@@ -1514,7 +1514,7 @@
           <p:cNvPr id="3" name="">
             <a:extLst xmlns:a="http://schemas.openxmlformats.org/drawingml/2006/main">
               <a:ext uri="{FF2B5EF4-FFF2-40B4-BE49-F238E27FC236}">
-                <a16:creationId xmlns:a16="http://schemas.microsoft.com/office/drawing/2014/main" id="{7E5F218A-F9B9-48F7-BF2E-B413DE395A02}"/>
+                <a16:creationId xmlns:a16="http://schemas.microsoft.com/office/drawing/2014/main" id="{465047E0-0F03-46C3-8955-C9E8D1914435}"/>
               </a:ext>
             </a:extLst>
           </p:cNvPr>
@@ -1594,7 +1594,7 @@
           <p:cNvPr id="4" name="">
             <a:extLst xmlns:a="http://schemas.openxmlformats.org/drawingml/2006/main">
               <a:ext uri="{FF2B5EF4-FFF2-40B4-BE49-F238E27FC236}">
-                <a16:creationId xmlns:a16="http://schemas.microsoft.com/office/drawing/2014/main" id="{D7162711-C4F6-455F-879A-EC7A7FBBBC4A}"/>
+                <a16:creationId xmlns:a16="http://schemas.microsoft.com/office/drawing/2014/main" id="{8FE4E231-CFB6-40C7-974B-837938E20820}"/>
               </a:ext>
             </a:extLst>
           </p:cNvPr>
@@ -1649,7 +1649,7 @@
     </p:spTree>
     <p:extLst>
       <p:ext uri="{BB962C8B-B14F-4D97-AF65-F5344CB8AC3E}">
-        <p14:creationId xmlns:p14="http://schemas.microsoft.com/office/powerpoint/2010/main" val="458715478"/>
+        <p14:creationId xmlns:p14="http://schemas.microsoft.com/office/powerpoint/2010/main" val="138409634"/>
       </p:ext>
     </p:extLst>
   </p:cSld>
@@ -1680,7 +1680,7 @@
           <p:cNvPr id="5" name="">
             <a:extLst xmlns:a="http://schemas.openxmlformats.org/drawingml/2006/main">
               <a:ext uri="{FF2B5EF4-FFF2-40B4-BE49-F238E27FC236}">
-                <a16:creationId xmlns:a16="http://schemas.microsoft.com/office/drawing/2014/main" id="{78599CFD-092D-4E0B-8082-B8F79F6780A8}"/>
+                <a16:creationId xmlns:a16="http://schemas.microsoft.com/office/drawing/2014/main" id="{BA8E1811-5830-4E22-99AF-CC90A7875D27}"/>
               </a:ext>
             </a:extLst>
           </p:cNvPr>
@@ -1737,7 +1737,7 @@
           <p:cNvPr id="2" name="">
             <a:extLst xmlns:a="http://schemas.openxmlformats.org/drawingml/2006/main">
               <a:ext uri="{FF2B5EF4-FFF2-40B4-BE49-F238E27FC236}">
-                <a16:creationId xmlns:a16="http://schemas.microsoft.com/office/drawing/2014/main" id="{C13727C6-5512-4A25-8525-13FBA61F2981}"/>
+                <a16:creationId xmlns:a16="http://schemas.microsoft.com/office/drawing/2014/main" id="{4A02C0B3-0174-43B0-A6F8-00C0E0D61697}"/>
               </a:ext>
             </a:extLst>
           </p:cNvPr>
@@ -1817,7 +1817,7 @@
           <p:cNvPr id="3" name="">
             <a:extLst xmlns:a="http://schemas.openxmlformats.org/drawingml/2006/main">
               <a:ext uri="{FF2B5EF4-FFF2-40B4-BE49-F238E27FC236}">
-                <a16:creationId xmlns:a16="http://schemas.microsoft.com/office/drawing/2014/main" id="{0BD5B351-B8F1-4E90-98C4-FDEEFE2FCD29}"/>
+                <a16:creationId xmlns:a16="http://schemas.microsoft.com/office/drawing/2014/main" id="{964C7700-515D-42FC-9C28-62C1956B6493}"/>
               </a:ext>
             </a:extLst>
           </p:cNvPr>
@@ -1874,7 +1874,7 @@
           <p:cNvPr id="4" name="">
             <a:extLst xmlns:a="http://schemas.openxmlformats.org/drawingml/2006/main">
               <a:ext uri="{FF2B5EF4-FFF2-40B4-BE49-F238E27FC236}">
-                <a16:creationId xmlns:a16="http://schemas.microsoft.com/office/drawing/2014/main" id="{213BC34A-6722-4995-9C26-81C67D368944}"/>
+                <a16:creationId xmlns:a16="http://schemas.microsoft.com/office/drawing/2014/main" id="{FDCF5B2C-953C-455D-832F-D58553DE3E96}"/>
               </a:ext>
             </a:extLst>
           </p:cNvPr>
@@ -1952,7 +1952,7 @@
     </p:spTree>
     <p:extLst>
       <p:ext uri="{BB962C8B-B14F-4D97-AF65-F5344CB8AC3E}">
-        <p14:creationId xmlns:p14="http://schemas.microsoft.com/office/powerpoint/2010/main" val="463898018"/>
+        <p14:creationId xmlns:p14="http://schemas.microsoft.com/office/powerpoint/2010/main" val="1167707846"/>
       </p:ext>
     </p:extLst>
   </p:cSld>
@@ -1983,7 +1983,7 @@
           <p:cNvPr id="5" name="">
             <a:extLst xmlns:a="http://schemas.openxmlformats.org/drawingml/2006/main">
               <a:ext uri="{FF2B5EF4-FFF2-40B4-BE49-F238E27FC236}">
-                <a16:creationId xmlns:a16="http://schemas.microsoft.com/office/drawing/2014/main" id="{1B6C157A-A88A-4B69-BFC8-CD9E3896E352}"/>
+                <a16:creationId xmlns:a16="http://schemas.microsoft.com/office/drawing/2014/main" id="{A958A6BD-381D-49DC-9940-481BF26AF575}"/>
               </a:ext>
             </a:extLst>
           </p:cNvPr>
@@ -2040,7 +2040,7 @@
           <p:cNvPr id="2" name="">
             <a:extLst xmlns:a="http://schemas.openxmlformats.org/drawingml/2006/main">
               <a:ext uri="{FF2B5EF4-FFF2-40B4-BE49-F238E27FC236}">
-                <a16:creationId xmlns:a16="http://schemas.microsoft.com/office/drawing/2014/main" id="{FA9EBA59-5A55-40CA-A554-207EB8C11C22}"/>
+                <a16:creationId xmlns:a16="http://schemas.microsoft.com/office/drawing/2014/main" id="{2F877083-5991-4C2C-8C02-2F380E49C2F6}"/>
               </a:ext>
             </a:extLst>
           </p:cNvPr>
@@ -2166,7 +2166,7 @@
           <p:cNvPr id="3" name="">
             <a:extLst xmlns:a="http://schemas.openxmlformats.org/drawingml/2006/main">
               <a:ext uri="{FF2B5EF4-FFF2-40B4-BE49-F238E27FC236}">
-                <a16:creationId xmlns:a16="http://schemas.microsoft.com/office/drawing/2014/main" id="{2BA53092-CBE6-4E84-AA1D-76AE9246B903}"/>
+                <a16:creationId xmlns:a16="http://schemas.microsoft.com/office/drawing/2014/main" id="{81EAA5F2-364B-45E8-863C-3B6425AB172C}"/>
               </a:ext>
             </a:extLst>
           </p:cNvPr>
@@ -2227,7 +2227,7 @@
           <p:nvPr/>
         </p:nvPicPr>
         <p:blipFill>
-          <a:blip xmlns:r="http://schemas.openxmlformats.org/officeDocument/2006/relationships" xmlns:a="http://schemas.openxmlformats.org/drawingml/2006/main" r:embed="Raa7abd3a95fa45eb"/>
+          <a:blip xmlns:r="http://schemas.openxmlformats.org/officeDocument/2006/relationships" xmlns:a="http://schemas.openxmlformats.org/drawingml/2006/main" r:embed="Rbc3d17ed61c14dc8"/>
           <a:stretch xmlns:a="http://schemas.openxmlformats.org/drawingml/2006/main"/>
         </p:blipFill>
         <p:spPr>
@@ -2243,7 +2243,7 @@
     </p:spTree>
     <p:extLst>
       <p:ext uri="{BB962C8B-B14F-4D97-AF65-F5344CB8AC3E}">
-        <p14:creationId xmlns:p14="http://schemas.microsoft.com/office/powerpoint/2010/main" val="1789042131"/>
+        <p14:creationId xmlns:p14="http://schemas.microsoft.com/office/powerpoint/2010/main" val="785516998"/>
       </p:ext>
     </p:extLst>
   </p:cSld>
@@ -2274,7 +2274,7 @@
           <p:cNvPr id="6" name="">
             <a:extLst xmlns:a="http://schemas.openxmlformats.org/drawingml/2006/main">
               <a:ext uri="{FF2B5EF4-FFF2-40B4-BE49-F238E27FC236}">
-                <a16:creationId xmlns:a16="http://schemas.microsoft.com/office/drawing/2014/main" id="{8ADB6E4B-7B10-4214-BCAC-F4EFF6E693C5}"/>
+                <a16:creationId xmlns:a16="http://schemas.microsoft.com/office/drawing/2014/main" id="{215A7D44-B876-46D9-9B66-2F9C96B2FE9F}"/>
               </a:ext>
             </a:extLst>
           </p:cNvPr>
@@ -2331,7 +2331,7 @@
           <p:cNvPr id="2" name="">
             <a:extLst xmlns:a="http://schemas.openxmlformats.org/drawingml/2006/main">
               <a:ext uri="{FF2B5EF4-FFF2-40B4-BE49-F238E27FC236}">
-                <a16:creationId xmlns:a16="http://schemas.microsoft.com/office/drawing/2014/main" id="{410C674C-F671-4359-97C7-56C4782A5FDF}"/>
+                <a16:creationId xmlns:a16="http://schemas.microsoft.com/office/drawing/2014/main" id="{1D544E6F-796F-42F1-A959-420C95C12171}"/>
               </a:ext>
             </a:extLst>
           </p:cNvPr>
@@ -2378,7 +2378,7 @@
                 <a:ea typeface="Helvetica Neue"/>
                 <a:cs typeface="Helvetica Neue"/>
               </a:rPr>
-              <a:t>1 sDAI → 1.180713732702892348 DAI</a:t>
+              <a:t>1 sDAI → 1.180831208759861486 DAI</a:t>
             </a:r>
           </a:p>
         </p:txBody>
@@ -2388,7 +2388,7 @@
           <p:cNvPr id="3" name="">
             <a:extLst xmlns:a="http://schemas.openxmlformats.org/drawingml/2006/main">
               <a:ext uri="{FF2B5EF4-FFF2-40B4-BE49-F238E27FC236}">
-                <a16:creationId xmlns:a16="http://schemas.microsoft.com/office/drawing/2014/main" id="{5749CC3C-71F9-4858-8804-D944F8E85C40}"/>
+                <a16:creationId xmlns:a16="http://schemas.microsoft.com/office/drawing/2014/main" id="{7B850B12-1C20-4E5D-9095-5C1B089FBFBF}"/>
               </a:ext>
             </a:extLst>
           </p:cNvPr>
@@ -2435,7 +2435,7 @@
                 <a:ea typeface="Helvetica Neue"/>
                 <a:cs typeface="Helvetica Neue"/>
               </a:rPr>
-              <a:t>Executed inside a private fork at source block 26,010,689.</a:t>
+              <a:t>Executed inside a private fork at source block 26,031,607.</a:t>
             </a:r>
           </a:p>
           <a:p xmlns:a="http://schemas.openxmlformats.org/drawingml/2006/main">
@@ -2468,7 +2468,7 @@
           <p:cNvPr id="4" name="">
             <a:extLst xmlns:a="http://schemas.openxmlformats.org/drawingml/2006/main">
               <a:ext uri="{FF2B5EF4-FFF2-40B4-BE49-F238E27FC236}">
-                <a16:creationId xmlns:a16="http://schemas.microsoft.com/office/drawing/2014/main" id="{DD8B3F6D-5187-43E4-B68B-77D8E6A8373B}"/>
+                <a16:creationId xmlns:a16="http://schemas.microsoft.com/office/drawing/2014/main" id="{92A1CDE4-BF6F-4614-A2C2-B854C6A0919E}"/>
               </a:ext>
             </a:extLst>
           </p:cNvPr>
@@ -2525,7 +2525,7 @@
           <p:cNvPr id="5" name="">
             <a:extLst xmlns:a="http://schemas.openxmlformats.org/drawingml/2006/main">
               <a:ext uri="{FF2B5EF4-FFF2-40B4-BE49-F238E27FC236}">
-                <a16:creationId xmlns:a16="http://schemas.microsoft.com/office/drawing/2014/main" id="{FDB70D00-669D-448E-B3E7-3F198A81F7EE}"/>
+                <a16:creationId xmlns:a16="http://schemas.microsoft.com/office/drawing/2014/main" id="{13010FF9-FBF6-45D3-9EE9-21DFE371C381}"/>
               </a:ext>
             </a:extLst>
           </p:cNvPr>
@@ -2572,7 +2572,7 @@
                 <a:ea typeface="Helvetica Neue"/>
                 <a:cs typeface="Helvetica Neue"/>
               </a:rPr>
-              <a:t>Historical experiment only. No mainnet transaction. Live adapter awaits repeat validation.</a:t>
+              <a:t>Second-provider repeat passed on 22 September. Live sDAI rehearsal enabled. No mainnet transaction.</a:t>
             </a:r>
           </a:p>
         </p:txBody>
@@ -2580,7 +2580,7 @@
     </p:spTree>
     <p:extLst>
       <p:ext uri="{BB962C8B-B14F-4D97-AF65-F5344CB8AC3E}">
-        <p14:creationId xmlns:p14="http://schemas.microsoft.com/office/powerpoint/2010/main" val="1432138312"/>
+        <p14:creationId xmlns:p14="http://schemas.microsoft.com/office/powerpoint/2010/main" val="857408688"/>
       </p:ext>
     </p:extLst>
   </p:cSld>
@@ -2611,7 +2611,7 @@
           <p:cNvPr id="6" name="">
             <a:extLst xmlns:a="http://schemas.openxmlformats.org/drawingml/2006/main">
               <a:ext uri="{FF2B5EF4-FFF2-40B4-BE49-F238E27FC236}">
-                <a16:creationId xmlns:a16="http://schemas.microsoft.com/office/drawing/2014/main" id="{0375EDEB-8449-421A-B941-76E992F8F1BD}"/>
+                <a16:creationId xmlns:a16="http://schemas.microsoft.com/office/drawing/2014/main" id="{F46F82BA-B230-4FF6-8D05-E734F9EA9C91}"/>
               </a:ext>
             </a:extLst>
           </p:cNvPr>
@@ -2668,7 +2668,7 @@
           <p:cNvPr id="2" name="">
             <a:extLst xmlns:a="http://schemas.openxmlformats.org/drawingml/2006/main">
               <a:ext uri="{FF2B5EF4-FFF2-40B4-BE49-F238E27FC236}">
-                <a16:creationId xmlns:a16="http://schemas.microsoft.com/office/drawing/2014/main" id="{F134C780-5EE8-4B5C-A8A8-D2CA1090584C}"/>
+                <a16:creationId xmlns:a16="http://schemas.microsoft.com/office/drawing/2014/main" id="{B9CD8815-2730-4AAE-B71C-E148E23A3036}"/>
               </a:ext>
             </a:extLst>
           </p:cNvPr>
@@ -2748,7 +2748,7 @@
           <p:cNvPr id="3" name="">
             <a:extLst xmlns:a="http://schemas.openxmlformats.org/drawingml/2006/main">
               <a:ext uri="{FF2B5EF4-FFF2-40B4-BE49-F238E27FC236}">
-                <a16:creationId xmlns:a16="http://schemas.microsoft.com/office/drawing/2014/main" id="{B133A95F-0B78-4097-AFBC-30367310869B}"/>
+                <a16:creationId xmlns:a16="http://schemas.microsoft.com/office/drawing/2014/main" id="{20FA5802-E7CD-47DD-BB6D-7CEB9332BC92}"/>
               </a:ext>
             </a:extLst>
           </p:cNvPr>
@@ -2805,7 +2805,7 @@
           <p:cNvPr id="4" name="">
             <a:extLst xmlns:a="http://schemas.openxmlformats.org/drawingml/2006/main">
               <a:ext uri="{FF2B5EF4-FFF2-40B4-BE49-F238E27FC236}">
-                <a16:creationId xmlns:a16="http://schemas.microsoft.com/office/drawing/2014/main" id="{38F1DEFE-6D5D-41C4-9E6A-126570950709}"/>
+                <a16:creationId xmlns:a16="http://schemas.microsoft.com/office/drawing/2014/main" id="{FEF908ED-6295-4865-B2C8-F9577FD77F80}"/>
               </a:ext>
             </a:extLst>
           </p:cNvPr>
@@ -2852,7 +2852,7 @@
                 <a:ea typeface="Helvetica Neue"/>
                 <a:cs typeface="Helvetica Neue"/>
               </a:rPr>
-              <a:t>Verified with the local web and API services stopped. Wallet-extension testing remains open.</a:t>
+              <a:t>Ethereum preflight passed with web and API stopped. Wallet-extension testing remains open.</a:t>
             </a:r>
           </a:p>
         </p:txBody>
@@ -2866,7 +2866,7 @@
           <p:nvPr/>
         </p:nvPicPr>
         <p:blipFill>
-          <a:blip xmlns:r="http://schemas.openxmlformats.org/officeDocument/2006/relationships" xmlns:a="http://schemas.openxmlformats.org/drawingml/2006/main" r:embed="Rb6960b1abe9d47d1"/>
+          <a:blip xmlns:r="http://schemas.openxmlformats.org/officeDocument/2006/relationships" xmlns:a="http://schemas.openxmlformats.org/drawingml/2006/main" r:embed="R2c423ad7404244bb"/>
           <a:stretch xmlns:a="http://schemas.openxmlformats.org/drawingml/2006/main"/>
         </p:blipFill>
         <p:spPr>
@@ -2882,7 +2882,7 @@
     </p:spTree>
     <p:extLst>
       <p:ext uri="{BB962C8B-B14F-4D97-AF65-F5344CB8AC3E}">
-        <p14:creationId xmlns:p14="http://schemas.microsoft.com/office/powerpoint/2010/main" val="392560721"/>
+        <p14:creationId xmlns:p14="http://schemas.microsoft.com/office/powerpoint/2010/main" val="1730012660"/>
       </p:ext>
     </p:extLst>
   </p:cSld>
@@ -2913,7 +2913,7 @@
           <p:cNvPr id="7" name="">
             <a:extLst xmlns:a="http://schemas.openxmlformats.org/drawingml/2006/main">
               <a:ext uri="{FF2B5EF4-FFF2-40B4-BE49-F238E27FC236}">
-                <a16:creationId xmlns:a16="http://schemas.microsoft.com/office/drawing/2014/main" id="{8218A7D3-EBCB-4447-B278-94411610EB30}"/>
+                <a16:creationId xmlns:a16="http://schemas.microsoft.com/office/drawing/2014/main" id="{0965E652-F848-448D-81A5-13E91021D62D}"/>
               </a:ext>
             </a:extLst>
           </p:cNvPr>
@@ -2970,7 +2970,7 @@
           <p:cNvPr id="2" name="">
             <a:extLst xmlns:a="http://schemas.openxmlformats.org/drawingml/2006/main">
               <a:ext uri="{FF2B5EF4-FFF2-40B4-BE49-F238E27FC236}">
-                <a16:creationId xmlns:a16="http://schemas.microsoft.com/office/drawing/2014/main" id="{2324477A-C88A-4F06-AF0B-30A1242B4886}"/>
+                <a16:creationId xmlns:a16="http://schemas.microsoft.com/office/drawing/2014/main" id="{501844CA-53A9-494F-955F-151442CE444A}"/>
               </a:ext>
             </a:extLst>
           </p:cNvPr>
@@ -3027,7 +3027,7 @@
           <p:cNvPr id="3" name="">
             <a:extLst xmlns:a="http://schemas.openxmlformats.org/drawingml/2006/main">
               <a:ext uri="{FF2B5EF4-FFF2-40B4-BE49-F238E27FC236}">
-                <a16:creationId xmlns:a16="http://schemas.microsoft.com/office/drawing/2014/main" id="{BC521125-C19E-4ACE-8032-88CC04851664}"/>
+                <a16:creationId xmlns:a16="http://schemas.microsoft.com/office/drawing/2014/main" id="{445584A8-89C2-4062-9D61-410444E68765}"/>
               </a:ext>
             </a:extLst>
           </p:cNvPr>
@@ -3074,7 +3074,7 @@
                 <a:ea typeface="Helvetica Neue"/>
                 <a:cs typeface="Helvetica Neue"/>
               </a:rPr>
-              <a:t>Four live vault cases</a:t>
+              <a:t>Live sDAI + four test vault cases</a:t>
             </a:r>
           </a:p>
           <a:p xmlns:a="http://schemas.openxmlformats.org/drawingml/2006/main">
@@ -3153,7 +3153,7 @@
           <p:cNvPr id="4" name="">
             <a:extLst xmlns:a="http://schemas.openxmlformats.org/drawingml/2006/main">
               <a:ext uri="{FF2B5EF4-FFF2-40B4-BE49-F238E27FC236}">
-                <a16:creationId xmlns:a16="http://schemas.microsoft.com/office/drawing/2014/main" id="{F3C031B7-B4B8-42F5-9A73-64B7E634FE95}"/>
+                <a16:creationId xmlns:a16="http://schemas.microsoft.com/office/drawing/2014/main" id="{700F8C41-0C64-4317-ACB9-D1ACF4EF1A59}"/>
               </a:ext>
             </a:extLst>
           </p:cNvPr>
@@ -3210,7 +3210,7 @@
           <p:cNvPr id="5" name="">
             <a:extLst xmlns:a="http://schemas.openxmlformats.org/drawingml/2006/main">
               <a:ext uri="{FF2B5EF4-FFF2-40B4-BE49-F238E27FC236}">
-                <a16:creationId xmlns:a16="http://schemas.microsoft.com/office/drawing/2014/main" id="{BC3792A0-F331-4677-8FDC-24ACB8424362}"/>
+                <a16:creationId xmlns:a16="http://schemas.microsoft.com/office/drawing/2014/main" id="{288483D3-E2F3-4015-B646-C66586D720E6}"/>
               </a:ext>
             </a:extLst>
           </p:cNvPr>
@@ -3257,7 +3257,7 @@
                 <a:ea typeface="Helvetica Neue"/>
                 <a:cs typeface="Helvetica Neue"/>
               </a:rPr>
-              <a:t>Reliable second-RPC repeat run</a:t>
+              <a:t>Measure RPC latency and failures</a:t>
             </a:r>
           </a:p>
           <a:p xmlns:a="http://schemas.openxmlformats.org/drawingml/2006/main">
@@ -3336,7 +3336,7 @@
           <p:cNvPr id="6" name="">
             <a:extLst xmlns:a="http://schemas.openxmlformats.org/drawingml/2006/main">
               <a:ext uri="{FF2B5EF4-FFF2-40B4-BE49-F238E27FC236}">
-                <a16:creationId xmlns:a16="http://schemas.microsoft.com/office/drawing/2014/main" id="{0FA846A9-5DF5-4F76-82B2-FAAA7B8DA666}"/>
+                <a16:creationId xmlns:a16="http://schemas.microsoft.com/office/drawing/2014/main" id="{15E9DAFD-2E37-45F0-8A6C-E7B41FB682ED}"/>
               </a:ext>
             </a:extLst>
           </p:cNvPr>
@@ -3414,7 +3414,7 @@
     </p:spTree>
     <p:extLst>
       <p:ext uri="{BB962C8B-B14F-4D97-AF65-F5344CB8AC3E}">
-        <p14:creationId xmlns:p14="http://schemas.microsoft.com/office/powerpoint/2010/main" val="622252494"/>
+        <p14:creationId xmlns:p14="http://schemas.microsoft.com/office/powerpoint/2010/main" val="1808003198"/>
       </p:ext>
     </p:extLst>
   </p:cSld>

</xml_diff>

<commit_message>
Update pitch deck with current test and reliability numbers
</commit_message>
<xml_diff>
--- a/docs/submission/ExitDrill-pitch.pptx
+++ b/docs/submission/ExitDrill-pitch.pptx
@@ -3120,7 +3120,7 @@
                 <a:ea typeface="Helvetica Neue"/>
                 <a:cs typeface="Helvetica Neue"/>
               </a:rPr>
-              <a:t>34 automated tests</a:t>
+              <a:t>41 tests · 30/30 hosted runs passed</a:t>
             </a:r>
           </a:p>
           <a:p xmlns:a="http://schemas.openxmlformats.org/drawingml/2006/main">
@@ -3257,7 +3257,7 @@
                 <a:ea typeface="Helvetica Neue"/>
                 <a:cs typeface="Helvetica Neue"/>
               </a:rPr>
-              <a:t>Measure RPC latency and failures</a:t>
+              <a:t>Load and cold-start testing</a:t>
             </a:r>
           </a:p>
           <a:p xmlns:a="http://schemas.openxmlformats.org/drawingml/2006/main">
@@ -3303,7 +3303,7 @@
                 <a:ea typeface="Helvetica Neue"/>
                 <a:cs typeface="Helvetica Neue"/>
               </a:rPr>
-              <a:t>Latency and accessibility audit</a:t>
+              <a:t>Full accessibility audit</a:t>
             </a:r>
           </a:p>
           <a:p xmlns:a="http://schemas.openxmlformats.org/drawingml/2006/main">

</xml_diff>